<commit_message>
Refine parchment card color and widen case-study layout
- Card/KPI background lightened #EDE8D0 -> #F7F4EA across the whole repo
- Page layout widened (--maxw 1180->1440px) and headline/prose width
  fixed so text isn't squeezed into a narrow column on wide screens
- Propagated to every asset carrying the old color: index.html (14
  sites incl. embedded diagrams), design tokens, Storyteller system
  prompt, CDI design-system index, the slide deck, the executive
  summary PDF (rebuilt), and 4 PNG exports

Full detail: Portfolio_Change_Tracker.md P-174 through P-179
</commit_message>
<xml_diff>
--- a/case-study/maldros_case_study_deck.pptx
+++ b/case-study/maldros_case_study_deck.pptx
@@ -1780,7 +1780,9 @@
             <a:avLst/>
           </a:prstGeom>
           <a:noFill/>
-          <a:ln/>
+          <a:ln>
+            <a:solidFill/>
+          </a:ln>
         </p:spPr>
         <p:txBody>
           <a:bodyPr wrap="square" lIns="0" tIns="0" rIns="0" bIns="0" rtlCol="0" anchor="ctr"/>
@@ -1819,7 +1821,9 @@
             <a:avLst/>
           </a:prstGeom>
           <a:noFill/>
-          <a:ln/>
+          <a:ln>
+            <a:solidFill/>
+          </a:ln>
         </p:spPr>
         <p:txBody>
           <a:bodyPr wrap="square" lIns="0" tIns="0" rIns="0" bIns="0" rtlCol="0" anchor="ctr"/>
@@ -1861,7 +1865,9 @@
             <a:avLst/>
           </a:prstGeom>
           <a:noFill/>
-          <a:ln/>
+          <a:ln>
+            <a:solidFill/>
+          </a:ln>
         </p:spPr>
         <p:txBody>
           <a:bodyPr wrap="square" lIns="0" tIns="0" rIns="0" bIns="0" rtlCol="0" anchor="ctr"/>
@@ -1876,7 +1882,7 @@
             <a:r>
               <a:rPr lang="en-US" sz="1900" dirty="0">
                 <a:solidFill>
-                  <a:srgbClr val="EDE8D0"/>
+                  <a:srgbClr val="F7F4EA"/>
                 </a:solidFill>
                 <a:latin typeface="Calibri" pitchFamily="34" charset="0"/>
                 <a:ea typeface="Calibri" pitchFamily="34" charset="-122"/>
@@ -1910,7 +1916,7 @@
             <a:r>
               <a:rPr lang="en-US" sz="1900" dirty="0">
                 <a:solidFill>
-                  <a:srgbClr val="EDE8D0"/>
+                  <a:srgbClr val="F7F4EA"/>
                 </a:solidFill>
                 <a:latin typeface="Calibri" pitchFamily="34" charset="0"/>
                 <a:ea typeface="Calibri" pitchFamily="34" charset="-122"/>
@@ -1937,7 +1943,9 @@
             <a:avLst/>
           </a:prstGeom>
           <a:noFill/>
-          <a:ln/>
+          <a:ln>
+            <a:solidFill/>
+          </a:ln>
         </p:spPr>
         <p:txBody>
           <a:bodyPr wrap="square" lIns="0" tIns="0" rIns="0" bIns="0" rtlCol="0" anchor="ctr"/>
@@ -2008,7 +2016,9 @@
             <a:avLst/>
           </a:prstGeom>
           <a:noFill/>
-          <a:ln/>
+          <a:ln>
+            <a:solidFill/>
+          </a:ln>
         </p:spPr>
         <p:txBody>
           <a:bodyPr wrap="square" lIns="0" tIns="0" rIns="0" bIns="0" rtlCol="0" anchor="ctr"/>
@@ -2047,7 +2057,9 @@
             <a:avLst/>
           </a:prstGeom>
           <a:noFill/>
-          <a:ln/>
+          <a:ln>
+            <a:solidFill/>
+          </a:ln>
         </p:spPr>
         <p:txBody>
           <a:bodyPr wrap="square" lIns="0" tIns="0" rIns="0" bIns="0" rtlCol="0" anchor="ctr"/>
@@ -2089,7 +2101,9 @@
             <a:avLst/>
           </a:prstGeom>
           <a:noFill/>
-          <a:ln/>
+          <a:ln>
+            <a:solidFill/>
+          </a:ln>
         </p:spPr>
         <p:txBody>
           <a:bodyPr wrap="square" lIns="0" tIns="0" rIns="0" bIns="0" rtlCol="0" anchor="ctr"/>
@@ -2133,7 +2147,7 @@
             </a:avLst>
           </a:prstGeom>
           <a:solidFill>
-            <a:srgbClr val="EDE8D0"/>
+            <a:srgbClr val="F7F4EA"/>
           </a:solidFill>
           <a:ln w="12700">
             <a:solidFill>
@@ -2162,7 +2176,9 @@
             <a:avLst/>
           </a:prstGeom>
           <a:noFill/>
-          <a:ln/>
+          <a:ln>
+            <a:solidFill/>
+          </a:ln>
         </p:spPr>
         <p:txBody>
           <a:bodyPr wrap="square" lIns="0" tIns="0" rIns="0" bIns="0" rtlCol="0" anchor="ctr"/>
@@ -2201,7 +2217,9 @@
             <a:avLst/>
           </a:prstGeom>
           <a:noFill/>
-          <a:ln/>
+          <a:ln>
+            <a:solidFill/>
+          </a:ln>
         </p:spPr>
         <p:txBody>
           <a:bodyPr wrap="square" lIns="0" tIns="0" rIns="0" bIns="0" rtlCol="0" anchor="t"/>
@@ -2243,7 +2261,9 @@
             <a:avLst/>
           </a:prstGeom>
           <a:noFill/>
-          <a:ln/>
+          <a:ln>
+            <a:solidFill/>
+          </a:ln>
         </p:spPr>
         <p:txBody>
           <a:bodyPr wrap="square" lIns="0" tIns="0" rIns="0" bIns="0" rtlCol="0" anchor="t"/>
@@ -2287,7 +2307,7 @@
             </a:avLst>
           </a:prstGeom>
           <a:solidFill>
-            <a:srgbClr val="EDE8D0"/>
+            <a:srgbClr val="F7F4EA"/>
           </a:solidFill>
           <a:ln w="12700">
             <a:solidFill>
@@ -2316,7 +2336,9 @@
             <a:avLst/>
           </a:prstGeom>
           <a:noFill/>
-          <a:ln/>
+          <a:ln>
+            <a:solidFill/>
+          </a:ln>
         </p:spPr>
         <p:txBody>
           <a:bodyPr wrap="square" lIns="0" tIns="0" rIns="0" bIns="0" rtlCol="0" anchor="ctr"/>
@@ -2355,7 +2377,9 @@
             <a:avLst/>
           </a:prstGeom>
           <a:noFill/>
-          <a:ln/>
+          <a:ln>
+            <a:solidFill/>
+          </a:ln>
         </p:spPr>
         <p:txBody>
           <a:bodyPr wrap="square" lIns="0" tIns="0" rIns="0" bIns="0" rtlCol="0" anchor="t"/>
@@ -2397,7 +2421,9 @@
             <a:avLst/>
           </a:prstGeom>
           <a:noFill/>
-          <a:ln/>
+          <a:ln>
+            <a:solidFill/>
+          </a:ln>
         </p:spPr>
         <p:txBody>
           <a:bodyPr wrap="square" lIns="0" tIns="0" rIns="0" bIns="0" rtlCol="0" anchor="t"/>
@@ -2441,7 +2467,7 @@
             </a:avLst>
           </a:prstGeom>
           <a:solidFill>
-            <a:srgbClr val="EDE8D0"/>
+            <a:srgbClr val="F7F4EA"/>
           </a:solidFill>
           <a:ln w="12700">
             <a:solidFill>
@@ -2470,7 +2496,9 @@
             <a:avLst/>
           </a:prstGeom>
           <a:noFill/>
-          <a:ln/>
+          <a:ln>
+            <a:solidFill/>
+          </a:ln>
         </p:spPr>
         <p:txBody>
           <a:bodyPr wrap="square" lIns="0" tIns="0" rIns="0" bIns="0" rtlCol="0" anchor="ctr"/>
@@ -2509,7 +2537,9 @@
             <a:avLst/>
           </a:prstGeom>
           <a:noFill/>
-          <a:ln/>
+          <a:ln>
+            <a:solidFill/>
+          </a:ln>
         </p:spPr>
         <p:txBody>
           <a:bodyPr wrap="square" lIns="0" tIns="0" rIns="0" bIns="0" rtlCol="0" anchor="t"/>
@@ -2551,7 +2581,9 @@
             <a:avLst/>
           </a:prstGeom>
           <a:noFill/>
-          <a:ln/>
+          <a:ln>
+            <a:solidFill/>
+          </a:ln>
         </p:spPr>
         <p:txBody>
           <a:bodyPr wrap="square" lIns="0" tIns="0" rIns="0" bIns="0" rtlCol="0" anchor="t"/>
@@ -2595,7 +2627,7 @@
             </a:avLst>
           </a:prstGeom>
           <a:solidFill>
-            <a:srgbClr val="EDE8D0"/>
+            <a:srgbClr val="F7F4EA"/>
           </a:solidFill>
           <a:ln w="12700">
             <a:solidFill>
@@ -2624,7 +2656,9 @@
             <a:avLst/>
           </a:prstGeom>
           <a:noFill/>
-          <a:ln/>
+          <a:ln>
+            <a:solidFill/>
+          </a:ln>
         </p:spPr>
         <p:txBody>
           <a:bodyPr wrap="square" lIns="0" tIns="0" rIns="0" bIns="0" rtlCol="0" anchor="ctr"/>
@@ -2663,7 +2697,9 @@
             <a:avLst/>
           </a:prstGeom>
           <a:noFill/>
-          <a:ln/>
+          <a:ln>
+            <a:solidFill/>
+          </a:ln>
         </p:spPr>
         <p:txBody>
           <a:bodyPr wrap="square" lIns="0" tIns="0" rIns="0" bIns="0" rtlCol="0" anchor="t"/>
@@ -2705,7 +2741,9 @@
             <a:avLst/>
           </a:prstGeom>
           <a:noFill/>
-          <a:ln/>
+          <a:ln>
+            <a:solidFill/>
+          </a:ln>
         </p:spPr>
         <p:txBody>
           <a:bodyPr wrap="square" lIns="0" tIns="0" rIns="0" bIns="0" rtlCol="0" anchor="t"/>
@@ -2747,7 +2785,9 @@
             <a:avLst/>
           </a:prstGeom>
           <a:noFill/>
-          <a:ln/>
+          <a:ln>
+            <a:solidFill/>
+          </a:ln>
         </p:spPr>
         <p:txBody>
           <a:bodyPr wrap="square" lIns="0" tIns="0" rIns="0" bIns="0" rtlCol="0" anchor="ctr"/>
@@ -2789,7 +2829,9 @@
             <a:avLst/>
           </a:prstGeom>
           <a:noFill/>
-          <a:ln/>
+          <a:ln>
+            <a:solidFill/>
+          </a:ln>
         </p:spPr>
         <p:txBody>
           <a:bodyPr wrap="square" lIns="0" tIns="0" rIns="0" bIns="0" rtlCol="0" anchor="ctr"/>
@@ -2860,7 +2902,9 @@
             <a:avLst/>
           </a:prstGeom>
           <a:noFill/>
-          <a:ln/>
+          <a:ln>
+            <a:solidFill/>
+          </a:ln>
         </p:spPr>
         <p:txBody>
           <a:bodyPr wrap="square" lIns="0" tIns="0" rIns="0" bIns="0" rtlCol="0" anchor="ctr"/>
@@ -2899,7 +2943,9 @@
             <a:avLst/>
           </a:prstGeom>
           <a:noFill/>
-          <a:ln/>
+          <a:ln>
+            <a:solidFill/>
+          </a:ln>
         </p:spPr>
         <p:txBody>
           <a:bodyPr wrap="square" lIns="0" tIns="0" rIns="0" bIns="0" rtlCol="0" anchor="ctr"/>
@@ -2941,7 +2987,9 @@
             <a:avLst/>
           </a:prstGeom>
           <a:noFill/>
-          <a:ln/>
+          <a:ln>
+            <a:solidFill/>
+          </a:ln>
         </p:spPr>
         <p:txBody>
           <a:bodyPr wrap="square" lIns="0" tIns="0" rIns="0" bIns="0" rtlCol="0" anchor="ctr"/>
@@ -2956,7 +3004,7 @@
             <a:r>
               <a:rPr lang="en-US" sz="1450" dirty="0">
                 <a:solidFill>
-                  <a:srgbClr val="EDE8D0"/>
+                  <a:srgbClr val="F7F4EA"/>
                 </a:solidFill>
                 <a:latin typeface="Calibri" pitchFamily="34" charset="0"/>
                 <a:ea typeface="Calibri" pitchFamily="34" charset="-122"/>
@@ -2983,7 +3031,9 @@
             <a:avLst/>
           </a:prstGeom>
           <a:noFill/>
-          <a:ln/>
+          <a:ln>
+            <a:solidFill/>
+          </a:ln>
         </p:spPr>
         <p:txBody>
           <a:bodyPr wrap="square" lIns="0" tIns="0" rIns="0" bIns="0" rtlCol="0" anchor="ctr"/>
@@ -2996,7 +3046,7 @@
             <a:r>
               <a:rPr lang="en-US" sz="1300" b="1" dirty="0">
                 <a:solidFill>
-                  <a:srgbClr val="EDE8D0"/>
+                  <a:srgbClr val="F7F4EA"/>
                 </a:solidFill>
                 <a:latin typeface="Calibri" pitchFamily="34" charset="0"/>
                 <a:ea typeface="Calibri" pitchFamily="34" charset="-122"/>
@@ -3037,7 +3087,9 @@
             <a:avLst/>
           </a:prstGeom>
           <a:noFill/>
-          <a:ln/>
+          <a:ln>
+            <a:solidFill/>
+          </a:ln>
         </p:spPr>
         <p:txBody>
           <a:bodyPr wrap="square" lIns="0" tIns="0" rIns="0" bIns="0" rtlCol="0" anchor="ctr"/>
@@ -3050,7 +3102,7 @@
             <a:r>
               <a:rPr lang="en-US" sz="1300" b="1" dirty="0">
                 <a:solidFill>
-                  <a:srgbClr val="EDE8D0"/>
+                  <a:srgbClr val="F7F4EA"/>
                 </a:solidFill>
                 <a:latin typeface="Calibri" pitchFamily="34" charset="0"/>
                 <a:ea typeface="Calibri" pitchFamily="34" charset="-122"/>
@@ -3091,7 +3143,9 @@
             <a:avLst/>
           </a:prstGeom>
           <a:noFill/>
-          <a:ln/>
+          <a:ln>
+            <a:solidFill/>
+          </a:ln>
         </p:spPr>
         <p:txBody>
           <a:bodyPr wrap="square" lIns="0" tIns="0" rIns="0" bIns="0" rtlCol="0" anchor="ctr"/>
@@ -3104,7 +3158,7 @@
             <a:r>
               <a:rPr lang="en-US" sz="1300" b="1" dirty="0">
                 <a:solidFill>
-                  <a:srgbClr val="EDE8D0"/>
+                  <a:srgbClr val="F7F4EA"/>
                 </a:solidFill>
                 <a:latin typeface="Calibri" pitchFamily="34" charset="0"/>
                 <a:ea typeface="Calibri" pitchFamily="34" charset="-122"/>
@@ -3145,7 +3199,9 @@
             <a:avLst/>
           </a:prstGeom>
           <a:noFill/>
-          <a:ln/>
+          <a:ln>
+            <a:solidFill/>
+          </a:ln>
         </p:spPr>
         <p:txBody>
           <a:bodyPr wrap="square" lIns="0" tIns="0" rIns="0" bIns="0" rtlCol="0" anchor="ctr"/>
@@ -3158,7 +3214,7 @@
             <a:r>
               <a:rPr lang="en-US" sz="1300" b="1" dirty="0">
                 <a:solidFill>
-                  <a:srgbClr val="EDE8D0"/>
+                  <a:srgbClr val="F7F4EA"/>
                 </a:solidFill>
                 <a:latin typeface="Calibri" pitchFamily="34" charset="0"/>
                 <a:ea typeface="Calibri" pitchFamily="34" charset="-122"/>
@@ -3203,7 +3259,9 @@
           <a:solidFill>
             <a:srgbClr val="C8882A"/>
           </a:solidFill>
-          <a:ln/>
+          <a:ln>
+            <a:solidFill/>
+          </a:ln>
         </p:spPr>
         <p:txBody>
           <a:bodyPr/>
@@ -3225,7 +3283,9 @@
             <a:avLst/>
           </a:prstGeom>
           <a:noFill/>
-          <a:ln/>
+          <a:ln>
+            <a:solidFill/>
+          </a:ln>
         </p:spPr>
         <p:txBody>
           <a:bodyPr wrap="square" lIns="0" tIns="0" rIns="0" bIns="0" rtlCol="0" anchor="ctr"/>
@@ -3267,7 +3327,9 @@
             <a:avLst/>
           </a:prstGeom>
           <a:noFill/>
-          <a:ln/>
+          <a:ln>
+            <a:solidFill/>
+          </a:ln>
         </p:spPr>
         <p:txBody>
           <a:bodyPr wrap="square" lIns="0" tIns="0" rIns="0" bIns="0" rtlCol="0" anchor="ctr"/>
@@ -3338,7 +3400,9 @@
             <a:avLst/>
           </a:prstGeom>
           <a:noFill/>
-          <a:ln/>
+          <a:ln>
+            <a:solidFill/>
+          </a:ln>
         </p:spPr>
         <p:txBody>
           <a:bodyPr wrap="square" lIns="0" tIns="0" rIns="0" bIns="0" rtlCol="0" anchor="ctr"/>
@@ -3377,7 +3441,9 @@
             <a:avLst/>
           </a:prstGeom>
           <a:noFill/>
-          <a:ln/>
+          <a:ln>
+            <a:solidFill/>
+          </a:ln>
         </p:spPr>
         <p:txBody>
           <a:bodyPr wrap="square" lIns="0" tIns="0" rIns="0" bIns="0" rtlCol="0" anchor="ctr"/>
@@ -3419,7 +3485,9 @@
             <a:avLst/>
           </a:prstGeom>
           <a:noFill/>
-          <a:ln/>
+          <a:ln>
+            <a:solidFill/>
+          </a:ln>
         </p:spPr>
         <p:txBody>
           <a:bodyPr wrap="square" lIns="0" tIns="0" rIns="0" bIns="0" rtlCol="0" anchor="ctr"/>
@@ -3463,7 +3531,7 @@
             </a:avLst>
           </a:prstGeom>
           <a:solidFill>
-            <a:srgbClr val="EDE8D0"/>
+            <a:srgbClr val="F7F4EA"/>
           </a:solidFill>
           <a:ln w="12700">
             <a:solidFill>
@@ -3492,7 +3560,9 @@
             <a:avLst/>
           </a:prstGeom>
           <a:noFill/>
-          <a:ln/>
+          <a:ln>
+            <a:solidFill/>
+          </a:ln>
         </p:spPr>
         <p:txBody>
           <a:bodyPr wrap="square" lIns="0" tIns="0" rIns="0" bIns="0" rtlCol="0" anchor="ctr"/>
@@ -3531,7 +3601,9 @@
             <a:avLst/>
           </a:prstGeom>
           <a:noFill/>
-          <a:ln/>
+          <a:ln>
+            <a:solidFill/>
+          </a:ln>
         </p:spPr>
         <p:txBody>
           <a:bodyPr wrap="square" lIns="0" tIns="0" rIns="0" bIns="0" rtlCol="0" anchor="t"/>
@@ -3573,7 +3645,9 @@
             <a:avLst/>
           </a:prstGeom>
           <a:noFill/>
-          <a:ln/>
+          <a:ln>
+            <a:solidFill/>
+          </a:ln>
         </p:spPr>
         <p:txBody>
           <a:bodyPr wrap="square" lIns="0" tIns="0" rIns="0" bIns="0" rtlCol="0" anchor="t"/>
@@ -3617,7 +3691,7 @@
             </a:avLst>
           </a:prstGeom>
           <a:solidFill>
-            <a:srgbClr val="EDE8D0"/>
+            <a:srgbClr val="F7F4EA"/>
           </a:solidFill>
           <a:ln w="12700">
             <a:solidFill>
@@ -3646,7 +3720,9 @@
             <a:avLst/>
           </a:prstGeom>
           <a:noFill/>
-          <a:ln/>
+          <a:ln>
+            <a:solidFill/>
+          </a:ln>
         </p:spPr>
         <p:txBody>
           <a:bodyPr wrap="square" lIns="0" tIns="0" rIns="0" bIns="0" rtlCol="0" anchor="ctr"/>
@@ -3685,7 +3761,9 @@
             <a:avLst/>
           </a:prstGeom>
           <a:noFill/>
-          <a:ln/>
+          <a:ln>
+            <a:solidFill/>
+          </a:ln>
         </p:spPr>
         <p:txBody>
           <a:bodyPr wrap="square" lIns="0" tIns="0" rIns="0" bIns="0" rtlCol="0" anchor="t"/>
@@ -3727,7 +3805,9 @@
             <a:avLst/>
           </a:prstGeom>
           <a:noFill/>
-          <a:ln/>
+          <a:ln>
+            <a:solidFill/>
+          </a:ln>
         </p:spPr>
         <p:txBody>
           <a:bodyPr wrap="square" lIns="0" tIns="0" rIns="0" bIns="0" rtlCol="0" anchor="t"/>
@@ -3771,7 +3851,7 @@
             </a:avLst>
           </a:prstGeom>
           <a:solidFill>
-            <a:srgbClr val="EDE8D0"/>
+            <a:srgbClr val="F7F4EA"/>
           </a:solidFill>
           <a:ln w="12700">
             <a:solidFill>
@@ -3800,7 +3880,9 @@
             <a:avLst/>
           </a:prstGeom>
           <a:noFill/>
-          <a:ln/>
+          <a:ln>
+            <a:solidFill/>
+          </a:ln>
         </p:spPr>
         <p:txBody>
           <a:bodyPr wrap="square" lIns="0" tIns="0" rIns="0" bIns="0" rtlCol="0" anchor="ctr"/>
@@ -3839,7 +3921,9 @@
             <a:avLst/>
           </a:prstGeom>
           <a:noFill/>
-          <a:ln/>
+          <a:ln>
+            <a:solidFill/>
+          </a:ln>
         </p:spPr>
         <p:txBody>
           <a:bodyPr wrap="square" lIns="0" tIns="0" rIns="0" bIns="0" rtlCol="0" anchor="t"/>
@@ -3881,7 +3965,9 @@
             <a:avLst/>
           </a:prstGeom>
           <a:noFill/>
-          <a:ln/>
+          <a:ln>
+            <a:solidFill/>
+          </a:ln>
         </p:spPr>
         <p:txBody>
           <a:bodyPr wrap="square" lIns="0" tIns="0" rIns="0" bIns="0" rtlCol="0" anchor="t"/>
@@ -3925,7 +4011,7 @@
             </a:avLst>
           </a:prstGeom>
           <a:solidFill>
-            <a:srgbClr val="EDE8D0"/>
+            <a:srgbClr val="F7F4EA"/>
           </a:solidFill>
           <a:ln w="12700">
             <a:solidFill>
@@ -3954,7 +4040,9 @@
             <a:avLst/>
           </a:prstGeom>
           <a:noFill/>
-          <a:ln/>
+          <a:ln>
+            <a:solidFill/>
+          </a:ln>
         </p:spPr>
         <p:txBody>
           <a:bodyPr wrap="square" lIns="0" tIns="0" rIns="0" bIns="0" rtlCol="0" anchor="ctr"/>
@@ -3993,7 +4081,9 @@
             <a:avLst/>
           </a:prstGeom>
           <a:noFill/>
-          <a:ln/>
+          <a:ln>
+            <a:solidFill/>
+          </a:ln>
         </p:spPr>
         <p:txBody>
           <a:bodyPr wrap="square" lIns="0" tIns="0" rIns="0" bIns="0" rtlCol="0" anchor="t"/>
@@ -4035,7 +4125,9 @@
             <a:avLst/>
           </a:prstGeom>
           <a:noFill/>
-          <a:ln/>
+          <a:ln>
+            <a:solidFill/>
+          </a:ln>
         </p:spPr>
         <p:txBody>
           <a:bodyPr wrap="square" lIns="0" tIns="0" rIns="0" bIns="0" rtlCol="0" anchor="t"/>
@@ -4077,7 +4169,9 @@
             <a:avLst/>
           </a:prstGeom>
           <a:noFill/>
-          <a:ln/>
+          <a:ln>
+            <a:solidFill/>
+          </a:ln>
         </p:spPr>
         <p:txBody>
           <a:bodyPr wrap="square" lIns="0" tIns="0" rIns="0" bIns="0" rtlCol="0" anchor="ctr"/>
@@ -4148,7 +4242,9 @@
             <a:avLst/>
           </a:prstGeom>
           <a:noFill/>
-          <a:ln/>
+          <a:ln>
+            <a:solidFill/>
+          </a:ln>
         </p:spPr>
         <p:txBody>
           <a:bodyPr wrap="square" lIns="0" tIns="0" rIns="0" bIns="0" rtlCol="0" anchor="ctr"/>
@@ -4187,7 +4283,9 @@
             <a:avLst/>
           </a:prstGeom>
           <a:noFill/>
-          <a:ln/>
+          <a:ln>
+            <a:solidFill/>
+          </a:ln>
         </p:spPr>
         <p:txBody>
           <a:bodyPr wrap="square" lIns="0" tIns="0" rIns="0" bIns="0" rtlCol="0" anchor="ctr"/>
@@ -4226,7 +4324,9 @@
             <a:avLst/>
           </a:prstGeom>
           <a:noFill/>
-          <a:ln/>
+          <a:ln>
+            <a:solidFill/>
+          </a:ln>
         </p:spPr>
         <p:txBody>
           <a:bodyPr wrap="square" lIns="0" tIns="0" rIns="0" bIns="0" rtlCol="0" anchor="ctr"/>
@@ -4275,6 +4375,9 @@
           <a:prstGeom prst="rect">
             <a:avLst/>
           </a:prstGeom>
+          <a:ln>
+            <a:solidFill/>
+          </a:ln>
         </p:spPr>
       </p:pic>
       <p:sp>
@@ -4292,7 +4395,9 @@
             <a:avLst/>
           </a:prstGeom>
           <a:noFill/>
-          <a:ln/>
+          <a:ln>
+            <a:solidFill/>
+          </a:ln>
         </p:spPr>
         <p:txBody>
           <a:bodyPr wrap="square" lIns="0" tIns="0" rIns="0" bIns="0" rtlCol="0" anchor="ctr"/>
@@ -4363,7 +4468,9 @@
             <a:avLst/>
           </a:prstGeom>
           <a:noFill/>
-          <a:ln/>
+          <a:ln>
+            <a:solidFill/>
+          </a:ln>
         </p:spPr>
         <p:txBody>
           <a:bodyPr wrap="square" lIns="0" tIns="0" rIns="0" bIns="0" rtlCol="0" anchor="ctr"/>
@@ -4402,7 +4509,9 @@
             <a:avLst/>
           </a:prstGeom>
           <a:noFill/>
-          <a:ln/>
+          <a:ln>
+            <a:solidFill/>
+          </a:ln>
         </p:spPr>
         <p:txBody>
           <a:bodyPr wrap="square" lIns="0" tIns="0" rIns="0" bIns="0" rtlCol="0" anchor="ctr"/>
@@ -4444,7 +4553,9 @@
             <a:avLst/>
           </a:prstGeom>
           <a:noFill/>
-          <a:ln/>
+          <a:ln>
+            <a:solidFill/>
+          </a:ln>
         </p:spPr>
         <p:txBody>
           <a:bodyPr wrap="square" lIns="0" tIns="0" rIns="0" bIns="0" rtlCol="0" anchor="ctr"/>
@@ -4488,7 +4599,7 @@
             </a:avLst>
           </a:prstGeom>
           <a:solidFill>
-            <a:srgbClr val="EDE8D0"/>
+            <a:srgbClr val="F7F4EA"/>
           </a:solidFill>
           <a:ln w="12700">
             <a:solidFill>
@@ -4517,7 +4628,9 @@
             <a:avLst/>
           </a:prstGeom>
           <a:noFill/>
-          <a:ln/>
+          <a:ln>
+            <a:solidFill/>
+          </a:ln>
         </p:spPr>
         <p:txBody>
           <a:bodyPr wrap="square" lIns="0" tIns="0" rIns="0" bIns="0" rtlCol="0" anchor="ctr"/>
@@ -4556,7 +4669,9 @@
             <a:avLst/>
           </a:prstGeom>
           <a:noFill/>
-          <a:ln/>
+          <a:ln>
+            <a:solidFill/>
+          </a:ln>
         </p:spPr>
         <p:txBody>
           <a:bodyPr wrap="square" lIns="0" tIns="0" rIns="0" bIns="0" rtlCol="0" anchor="t"/>
@@ -4600,7 +4715,7 @@
             </a:avLst>
           </a:prstGeom>
           <a:solidFill>
-            <a:srgbClr val="EDE8D0"/>
+            <a:srgbClr val="F7F4EA"/>
           </a:solidFill>
           <a:ln w="12700">
             <a:solidFill>
@@ -4629,7 +4744,9 @@
             <a:avLst/>
           </a:prstGeom>
           <a:noFill/>
-          <a:ln/>
+          <a:ln>
+            <a:solidFill/>
+          </a:ln>
         </p:spPr>
         <p:txBody>
           <a:bodyPr wrap="square" lIns="0" tIns="0" rIns="0" bIns="0" rtlCol="0" anchor="ctr"/>
@@ -4668,7 +4785,9 @@
             <a:avLst/>
           </a:prstGeom>
           <a:noFill/>
-          <a:ln/>
+          <a:ln>
+            <a:solidFill/>
+          </a:ln>
         </p:spPr>
         <p:txBody>
           <a:bodyPr wrap="square" lIns="0" tIns="0" rIns="0" bIns="0" rtlCol="0" anchor="t"/>
@@ -4712,7 +4831,7 @@
             </a:avLst>
           </a:prstGeom>
           <a:solidFill>
-            <a:srgbClr val="EDE8D0"/>
+            <a:srgbClr val="F7F4EA"/>
           </a:solidFill>
           <a:ln w="12700">
             <a:solidFill>
@@ -4741,7 +4860,9 @@
             <a:avLst/>
           </a:prstGeom>
           <a:noFill/>
-          <a:ln/>
+          <a:ln>
+            <a:solidFill/>
+          </a:ln>
         </p:spPr>
         <p:txBody>
           <a:bodyPr wrap="square" lIns="0" tIns="0" rIns="0" bIns="0" rtlCol="0" anchor="ctr"/>
@@ -4780,7 +4901,9 @@
             <a:avLst/>
           </a:prstGeom>
           <a:noFill/>
-          <a:ln/>
+          <a:ln>
+            <a:solidFill/>
+          </a:ln>
         </p:spPr>
         <p:txBody>
           <a:bodyPr wrap="square" lIns="0" tIns="0" rIns="0" bIns="0" rtlCol="0" anchor="t"/>
@@ -4822,7 +4945,9 @@
             <a:avLst/>
           </a:prstGeom>
           <a:noFill/>
-          <a:ln/>
+          <a:ln>
+            <a:solidFill/>
+          </a:ln>
         </p:spPr>
         <p:txBody>
           <a:bodyPr wrap="square" lIns="0" tIns="0" rIns="0" bIns="0" rtlCol="0" anchor="ctr"/>
@@ -4893,7 +5018,9 @@
             <a:avLst/>
           </a:prstGeom>
           <a:noFill/>
-          <a:ln/>
+          <a:ln>
+            <a:solidFill/>
+          </a:ln>
         </p:spPr>
         <p:txBody>
           <a:bodyPr wrap="square" lIns="0" tIns="0" rIns="0" bIns="0" rtlCol="0" anchor="ctr"/>
@@ -4932,7 +5059,9 @@
             <a:avLst/>
           </a:prstGeom>
           <a:noFill/>
-          <a:ln/>
+          <a:ln>
+            <a:solidFill/>
+          </a:ln>
         </p:spPr>
         <p:txBody>
           <a:bodyPr wrap="square" lIns="0" tIns="0" rIns="0" bIns="0" rtlCol="0" anchor="ctr"/>
@@ -4976,7 +5105,7 @@
             </a:avLst>
           </a:prstGeom>
           <a:solidFill>
-            <a:srgbClr val="EDE8D0"/>
+            <a:srgbClr val="F7F4EA"/>
           </a:solidFill>
           <a:ln w="12700">
             <a:solidFill>
@@ -5005,7 +5134,9 @@
             <a:avLst/>
           </a:prstGeom>
           <a:noFill/>
-          <a:ln/>
+          <a:ln>
+            <a:solidFill/>
+          </a:ln>
         </p:spPr>
         <p:txBody>
           <a:bodyPr wrap="square" lIns="0" tIns="0" rIns="0" bIns="0" rtlCol="0" anchor="ctr"/>
@@ -5047,7 +5178,9 @@
             <a:avLst/>
           </a:prstGeom>
           <a:noFill/>
-          <a:ln/>
+          <a:ln>
+            <a:solidFill/>
+          </a:ln>
         </p:spPr>
         <p:txBody>
           <a:bodyPr wrap="square" lIns="0" tIns="0" rIns="0" bIns="0" rtlCol="0" anchor="ctr"/>
@@ -5091,7 +5224,7 @@
             </a:avLst>
           </a:prstGeom>
           <a:solidFill>
-            <a:srgbClr val="EDE8D0"/>
+            <a:srgbClr val="F7F4EA"/>
           </a:solidFill>
           <a:ln w="12700">
             <a:solidFill>
@@ -5120,7 +5253,9 @@
             <a:avLst/>
           </a:prstGeom>
           <a:noFill/>
-          <a:ln/>
+          <a:ln>
+            <a:solidFill/>
+          </a:ln>
         </p:spPr>
         <p:txBody>
           <a:bodyPr wrap="square" lIns="0" tIns="0" rIns="0" bIns="0" rtlCol="0" anchor="ctr"/>
@@ -5162,7 +5297,9 @@
             <a:avLst/>
           </a:prstGeom>
           <a:noFill/>
-          <a:ln/>
+          <a:ln>
+            <a:solidFill/>
+          </a:ln>
         </p:spPr>
         <p:txBody>
           <a:bodyPr wrap="square" lIns="0" tIns="0" rIns="0" bIns="0" rtlCol="0" anchor="ctr"/>
@@ -5204,7 +5341,9 @@
             <a:avLst/>
           </a:prstGeom>
           <a:noFill/>
-          <a:ln/>
+          <a:ln>
+            <a:solidFill/>
+          </a:ln>
         </p:spPr>
         <p:txBody>
           <a:bodyPr wrap="square" lIns="0" tIns="0" rIns="0" bIns="0" rtlCol="0" anchor="ctr"/>
@@ -5243,7 +5382,9 @@
             <a:avLst/>
           </a:prstGeom>
           <a:noFill/>
-          <a:ln/>
+          <a:ln>
+            <a:solidFill/>
+          </a:ln>
         </p:spPr>
         <p:txBody>
           <a:bodyPr wrap="square" lIns="0" tIns="0" rIns="0" bIns="0" rtlCol="0" anchor="ctr"/>
@@ -5314,7 +5455,9 @@
             <a:avLst/>
           </a:prstGeom>
           <a:noFill/>
-          <a:ln/>
+          <a:ln>
+            <a:solidFill/>
+          </a:ln>
         </p:spPr>
         <p:txBody>
           <a:bodyPr wrap="square" lIns="0" tIns="0" rIns="0" bIns="0" rtlCol="0" anchor="ctr"/>
@@ -5353,7 +5496,9 @@
             <a:avLst/>
           </a:prstGeom>
           <a:noFill/>
-          <a:ln/>
+          <a:ln>
+            <a:solidFill/>
+          </a:ln>
         </p:spPr>
         <p:txBody>
           <a:bodyPr wrap="square" lIns="0" tIns="0" rIns="0" bIns="0" rtlCol="0" anchor="ctr"/>
@@ -5395,7 +5540,9 @@
             <a:avLst/>
           </a:prstGeom>
           <a:noFill/>
-          <a:ln/>
+          <a:ln>
+            <a:solidFill/>
+          </a:ln>
         </p:spPr>
         <p:txBody>
           <a:bodyPr wrap="square" lIns="0" tIns="0" rIns="0" bIns="0" rtlCol="0" anchor="ctr"/>
@@ -5441,7 +5588,9 @@
           <a:solidFill>
             <a:srgbClr val="0F2515"/>
           </a:solidFill>
-          <a:ln/>
+          <a:ln>
+            <a:solidFill/>
+          </a:ln>
         </p:spPr>
         <p:txBody>
           <a:bodyPr/>
@@ -5463,7 +5612,9 @@
             <a:avLst/>
           </a:prstGeom>
           <a:noFill/>
-          <a:ln/>
+          <a:ln>
+            <a:solidFill/>
+          </a:ln>
         </p:spPr>
         <p:txBody>
           <a:bodyPr wrap="square" lIns="0" tIns="0" rIns="0" bIns="0" rtlCol="0" anchor="ctr"/>
@@ -5502,7 +5653,9 @@
             <a:avLst/>
           </a:prstGeom>
           <a:noFill/>
-          <a:ln/>
+          <a:ln>
+            <a:solidFill/>
+          </a:ln>
         </p:spPr>
         <p:txBody>
           <a:bodyPr wrap="square" lIns="0" tIns="0" rIns="0" bIns="0" rtlCol="0" anchor="t"/>
@@ -5517,7 +5670,7 @@
             <a:r>
               <a:rPr lang="en-US" sz="1050" b="1" dirty="0">
                 <a:solidFill>
-                  <a:srgbClr val="EDE8D0"/>
+                  <a:srgbClr val="F7F4EA"/>
                 </a:solidFill>
                 <a:latin typeface="Calibri" pitchFamily="34" charset="0"/>
                 <a:ea typeface="Calibri" pitchFamily="34" charset="-122"/>
@@ -5548,7 +5701,9 @@
           <a:solidFill>
             <a:srgbClr val="0F2515"/>
           </a:solidFill>
-          <a:ln/>
+          <a:ln>
+            <a:solidFill/>
+          </a:ln>
         </p:spPr>
         <p:txBody>
           <a:bodyPr/>
@@ -5570,7 +5725,9 @@
             <a:avLst/>
           </a:prstGeom>
           <a:noFill/>
-          <a:ln/>
+          <a:ln>
+            <a:solidFill/>
+          </a:ln>
         </p:spPr>
         <p:txBody>
           <a:bodyPr wrap="square" lIns="0" tIns="0" rIns="0" bIns="0" rtlCol="0" anchor="ctr"/>
@@ -5609,7 +5766,9 @@
             <a:avLst/>
           </a:prstGeom>
           <a:noFill/>
-          <a:ln/>
+          <a:ln>
+            <a:solidFill/>
+          </a:ln>
         </p:spPr>
         <p:txBody>
           <a:bodyPr wrap="square" lIns="0" tIns="0" rIns="0" bIns="0" rtlCol="0" anchor="t"/>
@@ -5624,7 +5783,7 @@
             <a:r>
               <a:rPr lang="en-US" sz="1050" b="1" dirty="0">
                 <a:solidFill>
-                  <a:srgbClr val="EDE8D0"/>
+                  <a:srgbClr val="F7F4EA"/>
                 </a:solidFill>
                 <a:latin typeface="Calibri" pitchFamily="34" charset="0"/>
                 <a:ea typeface="Calibri" pitchFamily="34" charset="-122"/>
@@ -5655,7 +5814,9 @@
           <a:solidFill>
             <a:srgbClr val="0F2515"/>
           </a:solidFill>
-          <a:ln/>
+          <a:ln>
+            <a:solidFill/>
+          </a:ln>
         </p:spPr>
         <p:txBody>
           <a:bodyPr/>
@@ -5677,7 +5838,9 @@
             <a:avLst/>
           </a:prstGeom>
           <a:noFill/>
-          <a:ln/>
+          <a:ln>
+            <a:solidFill/>
+          </a:ln>
         </p:spPr>
         <p:txBody>
           <a:bodyPr wrap="square" lIns="0" tIns="0" rIns="0" bIns="0" rtlCol="0" anchor="ctr"/>
@@ -5716,7 +5879,9 @@
             <a:avLst/>
           </a:prstGeom>
           <a:noFill/>
-          <a:ln/>
+          <a:ln>
+            <a:solidFill/>
+          </a:ln>
         </p:spPr>
         <p:txBody>
           <a:bodyPr wrap="square" lIns="0" tIns="0" rIns="0" bIns="0" rtlCol="0" anchor="t"/>
@@ -5731,7 +5896,7 @@
             <a:r>
               <a:rPr lang="en-US" sz="1050" b="1" dirty="0">
                 <a:solidFill>
-                  <a:srgbClr val="EDE8D0"/>
+                  <a:srgbClr val="F7F4EA"/>
                 </a:solidFill>
                 <a:latin typeface="Calibri" pitchFamily="34" charset="0"/>
                 <a:ea typeface="Calibri" pitchFamily="34" charset="-122"/>
@@ -5762,7 +5927,9 @@
           <a:solidFill>
             <a:srgbClr val="0F2515"/>
           </a:solidFill>
-          <a:ln/>
+          <a:ln>
+            <a:solidFill/>
+          </a:ln>
         </p:spPr>
         <p:txBody>
           <a:bodyPr/>
@@ -5784,7 +5951,9 @@
             <a:avLst/>
           </a:prstGeom>
           <a:noFill/>
-          <a:ln/>
+          <a:ln>
+            <a:solidFill/>
+          </a:ln>
         </p:spPr>
         <p:txBody>
           <a:bodyPr wrap="square" lIns="0" tIns="0" rIns="0" bIns="0" rtlCol="0" anchor="ctr"/>
@@ -5823,7 +5992,9 @@
             <a:avLst/>
           </a:prstGeom>
           <a:noFill/>
-          <a:ln/>
+          <a:ln>
+            <a:solidFill/>
+          </a:ln>
         </p:spPr>
         <p:txBody>
           <a:bodyPr wrap="square" lIns="0" tIns="0" rIns="0" bIns="0" rtlCol="0" anchor="t"/>
@@ -5838,7 +6009,7 @@
             <a:r>
               <a:rPr lang="en-US" sz="1050" b="1" dirty="0">
                 <a:solidFill>
-                  <a:srgbClr val="EDE8D0"/>
+                  <a:srgbClr val="F7F4EA"/>
                 </a:solidFill>
                 <a:latin typeface="Calibri" pitchFamily="34" charset="0"/>
                 <a:ea typeface="Calibri" pitchFamily="34" charset="-122"/>
@@ -5869,7 +6040,9 @@
           <a:solidFill>
             <a:srgbClr val="C8882A"/>
           </a:solidFill>
-          <a:ln/>
+          <a:ln>
+            <a:solidFill/>
+          </a:ln>
         </p:spPr>
         <p:txBody>
           <a:bodyPr/>
@@ -5891,7 +6064,9 @@
             <a:avLst/>
           </a:prstGeom>
           <a:noFill/>
-          <a:ln/>
+          <a:ln>
+            <a:solidFill/>
+          </a:ln>
         </p:spPr>
         <p:txBody>
           <a:bodyPr wrap="square" lIns="0" tIns="0" rIns="0" bIns="0" rtlCol="0" anchor="ctr"/>
@@ -5930,7 +6105,9 @@
             <a:avLst/>
           </a:prstGeom>
           <a:noFill/>
-          <a:ln/>
+          <a:ln>
+            <a:solidFill/>
+          </a:ln>
         </p:spPr>
         <p:txBody>
           <a:bodyPr wrap="square" lIns="0" tIns="0" rIns="0" bIns="0" rtlCol="0" anchor="t"/>
@@ -5976,7 +6153,9 @@
           <a:solidFill>
             <a:srgbClr val="0F2515"/>
           </a:solidFill>
-          <a:ln/>
+          <a:ln>
+            <a:solidFill/>
+          </a:ln>
         </p:spPr>
         <p:txBody>
           <a:bodyPr/>
@@ -5998,7 +6177,9 @@
             <a:avLst/>
           </a:prstGeom>
           <a:noFill/>
-          <a:ln/>
+          <a:ln>
+            <a:solidFill/>
+          </a:ln>
         </p:spPr>
         <p:txBody>
           <a:bodyPr wrap="square" lIns="0" tIns="0" rIns="0" bIns="0" rtlCol="0" anchor="ctr"/>
@@ -6037,7 +6218,9 @@
             <a:avLst/>
           </a:prstGeom>
           <a:noFill/>
-          <a:ln/>
+          <a:ln>
+            <a:solidFill/>
+          </a:ln>
         </p:spPr>
         <p:txBody>
           <a:bodyPr wrap="square" lIns="0" tIns="0" rIns="0" bIns="0" rtlCol="0" anchor="t"/>
@@ -6052,7 +6235,7 @@
             <a:r>
               <a:rPr lang="en-US" sz="1050" b="1" dirty="0">
                 <a:solidFill>
-                  <a:srgbClr val="EDE8D0"/>
+                  <a:srgbClr val="F7F4EA"/>
                 </a:solidFill>
                 <a:latin typeface="Calibri" pitchFamily="34" charset="0"/>
                 <a:ea typeface="Calibri" pitchFamily="34" charset="-122"/>
@@ -6079,7 +6262,9 @@
             <a:avLst/>
           </a:prstGeom>
           <a:noFill/>
-          <a:ln/>
+          <a:ln>
+            <a:solidFill/>
+          </a:ln>
         </p:spPr>
         <p:txBody>
           <a:bodyPr wrap="square" lIns="0" tIns="0" rIns="0" bIns="0" rtlCol="0" anchor="ctr"/>
@@ -6150,7 +6335,9 @@
             <a:avLst/>
           </a:prstGeom>
           <a:noFill/>
-          <a:ln/>
+          <a:ln>
+            <a:solidFill/>
+          </a:ln>
         </p:spPr>
         <p:txBody>
           <a:bodyPr wrap="square" lIns="0" tIns="0" rIns="0" bIns="0" rtlCol="0" anchor="ctr"/>
@@ -6189,7 +6376,9 @@
             <a:avLst/>
           </a:prstGeom>
           <a:noFill/>
-          <a:ln/>
+          <a:ln>
+            <a:solidFill/>
+          </a:ln>
         </p:spPr>
         <p:txBody>
           <a:bodyPr wrap="square" lIns="0" tIns="0" rIns="0" bIns="0" rtlCol="0" anchor="ctr"/>
@@ -6717,7 +6906,7 @@
                       <a:tailEnd type="none" w="med" len="med"/>
                     </a:lnB>
                     <a:solidFill>
-                      <a:srgbClr val="EDE8D0"/>
+                      <a:srgbClr val="F7F4EA"/>
                     </a:solidFill>
                   </a:tcPr>
                 </a:tc>
@@ -6785,7 +6974,7 @@
                       <a:tailEnd type="none" w="med" len="med"/>
                     </a:lnB>
                     <a:solidFill>
-                      <a:srgbClr val="EDE8D0"/>
+                      <a:srgbClr val="F7F4EA"/>
                     </a:solidFill>
                   </a:tcPr>
                 </a:tc>
@@ -6853,7 +7042,7 @@
                       <a:tailEnd type="none" w="med" len="med"/>
                     </a:lnB>
                     <a:solidFill>
-                      <a:srgbClr val="EDE8D0"/>
+                      <a:srgbClr val="F7F4EA"/>
                     </a:solidFill>
                   </a:tcPr>
                 </a:tc>
@@ -7129,7 +7318,7 @@
                       <a:tailEnd type="none" w="med" len="med"/>
                     </a:lnB>
                     <a:solidFill>
-                      <a:srgbClr val="EDE8D0"/>
+                      <a:srgbClr val="F7F4EA"/>
                     </a:solidFill>
                   </a:tcPr>
                 </a:tc>
@@ -7197,7 +7386,7 @@
                       <a:tailEnd type="none" w="med" len="med"/>
                     </a:lnB>
                     <a:solidFill>
-                      <a:srgbClr val="EDE8D0"/>
+                      <a:srgbClr val="F7F4EA"/>
                     </a:solidFill>
                   </a:tcPr>
                 </a:tc>
@@ -7265,7 +7454,7 @@
                       <a:tailEnd type="none" w="med" len="med"/>
                     </a:lnB>
                     <a:solidFill>
-                      <a:srgbClr val="EDE8D0"/>
+                      <a:srgbClr val="F7F4EA"/>
                     </a:solidFill>
                   </a:tcPr>
                 </a:tc>
@@ -7541,7 +7730,7 @@
                       <a:tailEnd type="none" w="med" len="med"/>
                     </a:lnB>
                     <a:solidFill>
-                      <a:srgbClr val="EDE8D0"/>
+                      <a:srgbClr val="F7F4EA"/>
                     </a:solidFill>
                   </a:tcPr>
                 </a:tc>
@@ -7609,7 +7798,7 @@
                       <a:tailEnd type="none" w="med" len="med"/>
                     </a:lnB>
                     <a:solidFill>
-                      <a:srgbClr val="EDE8D0"/>
+                      <a:srgbClr val="F7F4EA"/>
                     </a:solidFill>
                   </a:tcPr>
                 </a:tc>
@@ -7677,7 +7866,7 @@
                       <a:tailEnd type="none" w="med" len="med"/>
                     </a:lnB>
                     <a:solidFill>
-                      <a:srgbClr val="EDE8D0"/>
+                      <a:srgbClr val="F7F4EA"/>
                     </a:solidFill>
                   </a:tcPr>
                 </a:tc>
@@ -7701,7 +7890,9 @@
             <a:avLst/>
           </a:prstGeom>
           <a:noFill/>
-          <a:ln/>
+          <a:ln>
+            <a:solidFill/>
+          </a:ln>
         </p:spPr>
         <p:txBody>
           <a:bodyPr wrap="square" lIns="0" tIns="0" rIns="0" bIns="0" rtlCol="0" anchor="ctr"/>
@@ -7743,7 +7934,9 @@
             <a:avLst/>
           </a:prstGeom>
           <a:noFill/>
-          <a:ln/>
+          <a:ln>
+            <a:solidFill/>
+          </a:ln>
         </p:spPr>
         <p:txBody>
           <a:bodyPr wrap="square" lIns="0" tIns="0" rIns="0" bIns="0" rtlCol="0" anchor="ctr"/>
@@ -7814,7 +8007,9 @@
             <a:avLst/>
           </a:prstGeom>
           <a:noFill/>
-          <a:ln/>
+          <a:ln>
+            <a:solidFill/>
+          </a:ln>
         </p:spPr>
         <p:txBody>
           <a:bodyPr wrap="square" lIns="0" tIns="0" rIns="0" bIns="0" rtlCol="0" anchor="ctr"/>
@@ -7853,7 +8048,9 @@
             <a:avLst/>
           </a:prstGeom>
           <a:noFill/>
-          <a:ln/>
+          <a:ln>
+            <a:solidFill/>
+          </a:ln>
         </p:spPr>
         <p:txBody>
           <a:bodyPr wrap="square" lIns="0" tIns="0" rIns="0" bIns="0" rtlCol="0" anchor="ctr"/>
@@ -7895,7 +8092,9 @@
             <a:avLst/>
           </a:prstGeom>
           <a:noFill/>
-          <a:ln/>
+          <a:ln>
+            <a:solidFill/>
+          </a:ln>
         </p:spPr>
         <p:txBody>
           <a:bodyPr wrap="square" lIns="0" tIns="0" rIns="0" bIns="0" rtlCol="0" anchor="ctr"/>
@@ -7939,7 +8138,7 @@
             </a:avLst>
           </a:prstGeom>
           <a:solidFill>
-            <a:srgbClr val="EDE8D0"/>
+            <a:srgbClr val="F7F4EA"/>
           </a:solidFill>
           <a:ln w="12700">
             <a:solidFill>
@@ -7968,7 +8167,9 @@
             <a:avLst/>
           </a:prstGeom>
           <a:noFill/>
-          <a:ln/>
+          <a:ln>
+            <a:solidFill/>
+          </a:ln>
         </p:spPr>
         <p:txBody>
           <a:bodyPr wrap="square" lIns="0" tIns="0" rIns="0" bIns="0" rtlCol="0" anchor="ctr"/>
@@ -8007,7 +8208,9 @@
             <a:avLst/>
           </a:prstGeom>
           <a:noFill/>
-          <a:ln/>
+          <a:ln>
+            <a:solidFill/>
+          </a:ln>
         </p:spPr>
         <p:txBody>
           <a:bodyPr wrap="square" lIns="0" tIns="0" rIns="0" bIns="0" rtlCol="0" anchor="t"/>
@@ -8051,7 +8254,7 @@
             </a:avLst>
           </a:prstGeom>
           <a:solidFill>
-            <a:srgbClr val="EDE8D0"/>
+            <a:srgbClr val="F7F4EA"/>
           </a:solidFill>
           <a:ln w="12700">
             <a:solidFill>
@@ -8080,7 +8283,9 @@
             <a:avLst/>
           </a:prstGeom>
           <a:noFill/>
-          <a:ln/>
+          <a:ln>
+            <a:solidFill/>
+          </a:ln>
         </p:spPr>
         <p:txBody>
           <a:bodyPr wrap="square" lIns="0" tIns="0" rIns="0" bIns="0" rtlCol="0" anchor="ctr"/>
@@ -8119,7 +8324,9 @@
             <a:avLst/>
           </a:prstGeom>
           <a:noFill/>
-          <a:ln/>
+          <a:ln>
+            <a:solidFill/>
+          </a:ln>
         </p:spPr>
         <p:txBody>
           <a:bodyPr wrap="square" lIns="0" tIns="0" rIns="0" bIns="0" rtlCol="0" anchor="t"/>
@@ -8163,7 +8370,7 @@
             </a:avLst>
           </a:prstGeom>
           <a:solidFill>
-            <a:srgbClr val="EDE8D0"/>
+            <a:srgbClr val="F7F4EA"/>
           </a:solidFill>
           <a:ln w="12700">
             <a:solidFill>
@@ -8192,7 +8399,9 @@
             <a:avLst/>
           </a:prstGeom>
           <a:noFill/>
-          <a:ln/>
+          <a:ln>
+            <a:solidFill/>
+          </a:ln>
         </p:spPr>
         <p:txBody>
           <a:bodyPr wrap="square" lIns="0" tIns="0" rIns="0" bIns="0" rtlCol="0" anchor="ctr"/>
@@ -8231,7 +8440,9 @@
             <a:avLst/>
           </a:prstGeom>
           <a:noFill/>
-          <a:ln/>
+          <a:ln>
+            <a:solidFill/>
+          </a:ln>
         </p:spPr>
         <p:txBody>
           <a:bodyPr wrap="square" lIns="0" tIns="0" rIns="0" bIns="0" rtlCol="0" anchor="t"/>
@@ -8275,7 +8486,7 @@
             </a:avLst>
           </a:prstGeom>
           <a:solidFill>
-            <a:srgbClr val="EDE8D0"/>
+            <a:srgbClr val="F7F4EA"/>
           </a:solidFill>
           <a:ln w="12700">
             <a:solidFill>
@@ -8304,7 +8515,9 @@
             <a:avLst/>
           </a:prstGeom>
           <a:noFill/>
-          <a:ln/>
+          <a:ln>
+            <a:solidFill/>
+          </a:ln>
         </p:spPr>
         <p:txBody>
           <a:bodyPr wrap="square" lIns="0" tIns="0" rIns="0" bIns="0" rtlCol="0" anchor="ctr"/>
@@ -8357,7 +8570,9 @@
             <a:avLst/>
           </a:prstGeom>
           <a:noFill/>
-          <a:ln/>
+          <a:ln>
+            <a:solidFill/>
+          </a:ln>
         </p:spPr>
         <p:txBody>
           <a:bodyPr wrap="square" lIns="0" tIns="0" rIns="0" bIns="0" rtlCol="0" anchor="ctr"/>
@@ -8428,7 +8643,9 @@
             <a:avLst/>
           </a:prstGeom>
           <a:noFill/>
-          <a:ln/>
+          <a:ln>
+            <a:solidFill/>
+          </a:ln>
         </p:spPr>
         <p:txBody>
           <a:bodyPr wrap="square" lIns="0" tIns="0" rIns="0" bIns="0" rtlCol="0" anchor="ctr"/>
@@ -8467,7 +8684,9 @@
             <a:avLst/>
           </a:prstGeom>
           <a:noFill/>
-          <a:ln/>
+          <a:ln>
+            <a:solidFill/>
+          </a:ln>
         </p:spPr>
         <p:txBody>
           <a:bodyPr wrap="square" lIns="0" tIns="0" rIns="0" bIns="0" rtlCol="0" anchor="ctr"/>
@@ -8506,7 +8725,9 @@
             <a:avLst/>
           </a:prstGeom>
           <a:noFill/>
-          <a:ln/>
+          <a:ln>
+            <a:solidFill/>
+          </a:ln>
         </p:spPr>
         <p:txBody>
           <a:bodyPr wrap="square" lIns="0" tIns="0" rIns="0" bIns="0" rtlCol="0" anchor="ctr"/>
@@ -8550,7 +8771,7 @@
             </a:avLst>
           </a:prstGeom>
           <a:solidFill>
-            <a:srgbClr val="EDE8D0"/>
+            <a:srgbClr val="F7F4EA"/>
           </a:solidFill>
           <a:ln w="12700">
             <a:solidFill>
@@ -8579,7 +8800,9 @@
             <a:avLst/>
           </a:prstGeom>
           <a:noFill/>
-          <a:ln/>
+          <a:ln>
+            <a:solidFill/>
+          </a:ln>
         </p:spPr>
         <p:txBody>
           <a:bodyPr wrap="square" lIns="0" tIns="0" rIns="0" bIns="0" rtlCol="0" anchor="ctr"/>
@@ -8618,7 +8841,9 @@
             <a:avLst/>
           </a:prstGeom>
           <a:noFill/>
-          <a:ln/>
+          <a:ln>
+            <a:solidFill/>
+          </a:ln>
         </p:spPr>
         <p:txBody>
           <a:bodyPr wrap="square" lIns="0" tIns="0" rIns="0" bIns="0" rtlCol="0" anchor="t"/>
@@ -8660,7 +8885,9 @@
             <a:avLst/>
           </a:prstGeom>
           <a:noFill/>
-          <a:ln/>
+          <a:ln>
+            <a:solidFill/>
+          </a:ln>
         </p:spPr>
         <p:txBody>
           <a:bodyPr wrap="square" lIns="0" tIns="0" rIns="0" bIns="0" rtlCol="0" anchor="t"/>
@@ -8704,7 +8931,7 @@
             </a:avLst>
           </a:prstGeom>
           <a:solidFill>
-            <a:srgbClr val="EDE8D0"/>
+            <a:srgbClr val="F7F4EA"/>
           </a:solidFill>
           <a:ln w="12700">
             <a:solidFill>
@@ -8733,7 +8960,9 @@
             <a:avLst/>
           </a:prstGeom>
           <a:noFill/>
-          <a:ln/>
+          <a:ln>
+            <a:solidFill/>
+          </a:ln>
         </p:spPr>
         <p:txBody>
           <a:bodyPr wrap="square" lIns="0" tIns="0" rIns="0" bIns="0" rtlCol="0" anchor="ctr"/>
@@ -8772,7 +9001,9 @@
             <a:avLst/>
           </a:prstGeom>
           <a:noFill/>
-          <a:ln/>
+          <a:ln>
+            <a:solidFill/>
+          </a:ln>
         </p:spPr>
         <p:txBody>
           <a:bodyPr wrap="square" lIns="0" tIns="0" rIns="0" bIns="0" rtlCol="0" anchor="t"/>
@@ -8814,7 +9045,9 @@
             <a:avLst/>
           </a:prstGeom>
           <a:noFill/>
-          <a:ln/>
+          <a:ln>
+            <a:solidFill/>
+          </a:ln>
         </p:spPr>
         <p:txBody>
           <a:bodyPr wrap="square" lIns="0" tIns="0" rIns="0" bIns="0" rtlCol="0" anchor="t"/>
@@ -8858,7 +9091,7 @@
             </a:avLst>
           </a:prstGeom>
           <a:solidFill>
-            <a:srgbClr val="EDE8D0"/>
+            <a:srgbClr val="F7F4EA"/>
           </a:solidFill>
           <a:ln w="12700">
             <a:solidFill>
@@ -8887,7 +9120,9 @@
             <a:avLst/>
           </a:prstGeom>
           <a:noFill/>
-          <a:ln/>
+          <a:ln>
+            <a:solidFill/>
+          </a:ln>
         </p:spPr>
         <p:txBody>
           <a:bodyPr wrap="square" lIns="0" tIns="0" rIns="0" bIns="0" rtlCol="0" anchor="ctr"/>
@@ -8926,7 +9161,9 @@
             <a:avLst/>
           </a:prstGeom>
           <a:noFill/>
-          <a:ln/>
+          <a:ln>
+            <a:solidFill/>
+          </a:ln>
         </p:spPr>
         <p:txBody>
           <a:bodyPr wrap="square" lIns="0" tIns="0" rIns="0" bIns="0" rtlCol="0" anchor="t"/>
@@ -8968,7 +9205,9 @@
             <a:avLst/>
           </a:prstGeom>
           <a:noFill/>
-          <a:ln/>
+          <a:ln>
+            <a:solidFill/>
+          </a:ln>
         </p:spPr>
         <p:txBody>
           <a:bodyPr wrap="square" lIns="0" tIns="0" rIns="0" bIns="0" rtlCol="0" anchor="t"/>
@@ -9010,7 +9249,9 @@
             <a:avLst/>
           </a:prstGeom>
           <a:noFill/>
-          <a:ln/>
+          <a:ln>
+            <a:solidFill/>
+          </a:ln>
         </p:spPr>
         <p:txBody>
           <a:bodyPr wrap="square" lIns="0" tIns="0" rIns="0" bIns="0" rtlCol="0" anchor="ctr"/>

</xml_diff>